<commit_message>
docs(entrega): notebook ejecutado, laminas actualizadas y aporte por integrante
- Notebook de analisis con sus 34 salidas guardadas.
- Diapositivas: S0 y S1 con la version final, cifras de S6 y de la corrida
  rotuladas como referencia, recall global de LSH y lamina nueva de correcciones.
- README: columna de aporte concreto por integrante.
- Informe: memoria del indice IVF en la seccion de similitud.
</commit_message>
<xml_diff>
--- a/report/Presentacion_Final.pptx
+++ b/report/Presentacion_Final.pptx
@@ -18,6 +18,7 @@
     <p:sldId id="266" r:id="rId12"/>
     <p:sldId id="267" r:id="rId13"/>
     <p:sldId id="268" r:id="rId14"/>
+    <p:sldId id="269" r:id="rId20"/>
   </p:sldIdLst>
   <p:notesMasterIdLst>
     <p:notesMasterId r:id="rId15"/>
@@ -7010,7 +7011,7 @@
                   <a:schemeClr val="tx2"/>
                 </a:solidFill>
               </a:rPr>
-              <a:t>eventos de fraude bloqueados antes de llegar a S4</a:t>
+              <a:t>bloqueados en la corrida de referencia (v1)</a:t>
             </a:r>
             <a:endParaRPr lang="en-US" sz="1250" dirty="0"/>
           </a:p>
@@ -7801,6 +7802,41 @@
 </p:sld>
 </file>
 
+<file path=ppt/slides/slide14.xml><?xml version="1.0" encoding="utf-8"?>
+<p:sld xmlns:a="http://schemas.openxmlformats.org/drawingml/2006/main" xmlns:p="http://schemas.openxmlformats.org/presentationml/2006/main" xmlns:r="http://schemas.openxmlformats.org/officeDocument/2006/relationships">
+  <p:cSld>
+    <p:spTree>
+      <p:nvGrpSpPr>
+        <p:cNvPr id="1" name=""/>
+        <p:cNvGrpSpPr/>
+        <p:nvPr/>
+      </p:nvGrpSpPr>
+      <p:grpSpPr/>
+      <p:sp>
+        <p:nvSpPr>
+          <p:cNvPr id="2" name="Title 1"/>
+          <p:cNvSpPr>
+            <a:spLocks noGrp="1"/>
+          </p:cNvSpPr>
+          <p:nvPr>
+            <p:ph type="title" idx="100"/>
+          </p:nvPr>
+        </p:nvSpPr>
+        <p:spPr/>
+        <p:txBody>
+          <a:bodyPr/>
+          <a:lstStyle/>
+          <a:p/>
+        </p:txBody>
+      </p:sp>
+    </p:spTree>
+  </p:cSld>
+  <p:clrMapOvr>
+    <a:masterClrMapping/>
+  </p:clrMapOvr>
+</p:sld>
+</file>
+
 <file path=ppt/slides/slide2.xml><?xml version="1.0" encoding="utf-8"?>
 <p:sld xmlns:a="http://schemas.openxmlformats.org/drawingml/2006/main" xmlns:r="http://schemas.openxmlformats.org/officeDocument/2006/relationships" xmlns:p="http://schemas.openxmlformats.org/presentationml/2006/main">
   <p:cSld name="Slide 2">
@@ -9157,6 +9193,10 @@
             <a:prstDash val="solid"/>
           </a:ln>
         </p:spPr>
+        <p:txBody>
+          <a:bodyPr/>
+          <a:p/>
+        </p:txBody>
       </p:sp>
       <p:sp>
         <p:nvSpPr>
@@ -9184,6 +9224,10 @@
             <a:prstDash val="solid"/>
           </a:ln>
         </p:spPr>
+        <p:txBody>
+          <a:bodyPr/>
+          <a:p/>
+        </p:txBody>
       </p:sp>
       <p:sp>
         <p:nvSpPr>
@@ -9312,7 +9356,7 @@
                   <a:schemeClr val="tx2"/>
                 </a:solidFill>
               </a:rPr>
-              <a:t>Capacidad máxima: si se llena, descarta y cuenta (backpressure)</a:t>
+              <a:t>Capacidad de un lote: si se llena, el productor se detiene y se contabiliza</a:t>
             </a:r>
             <a:endParaRPr lang="en-US" sz="1500" dirty="0"/>
           </a:p>
@@ -9437,6 +9481,10 @@
             <a:prstDash val="solid"/>
           </a:ln>
         </p:spPr>
+        <p:txBody>
+          <a:bodyPr/>
+          <a:p/>
+        </p:txBody>
       </p:sp>
       <p:sp>
         <p:nvSpPr>
@@ -9464,6 +9512,10 @@
             <a:prstDash val="solid"/>
           </a:ln>
         </p:spPr>
+        <p:txBody>
+          <a:bodyPr/>
+          <a:p/>
+        </p:txBody>
       </p:sp>
       <p:sp>
         <p:nvSpPr>
@@ -9592,7 +9644,7 @@
                   <a:schemeClr val="tx2"/>
                 </a:solidFill>
               </a:rPr>
-              <a:t>Busca cada id en la ventana ordenada de los últimos 500K</a:t>
+              <a:t>Deduplica contra una ventana de 500 mil ids con conjunto hash</a:t>
             </a:r>
             <a:endParaRPr lang="en-US" sz="1500" dirty="0"/>
           </a:p>
@@ -9610,7 +9662,7 @@
                   <a:schemeClr val="tx2"/>
                 </a:solidFill>
               </a:rPr>
-              <a:t>O(b log W) por lote</a:t>
+              <a:t>O(1) por evento; memoria acotada a la ventana</a:t>
             </a:r>
             <a:endParaRPr lang="en-US" sz="1500" dirty="0"/>
           </a:p>
@@ -11053,6 +11105,10 @@
             <a:prstDash val="solid"/>
           </a:ln>
         </p:spPr>
+        <p:txBody>
+          <a:bodyPr/>
+          <a:p/>
+        </p:txBody>
       </p:sp>
       <p:sp>
         <p:nvSpPr>
@@ -11243,7 +11299,7 @@
                   <a:schemeClr val="tx2"/>
                 </a:solidFill>
               </a:rPr>
-              <a:t>precisión: lo demás son cuentas reales con ráfagas de compra</a:t>
+              <a:t>precisión en la corrida de referencia (v1)</a:t>
             </a:r>
             <a:endParaRPr lang="en-US" sz="1250" dirty="0"/>
           </a:p>
@@ -11318,7 +11374,7 @@
                   <a:schemeClr val="tx2"/>
                 </a:solidFill>
               </a:rPr>
-              <a:t>recall: las primeras compras de cada ráfaga pasan</a:t>
+              <a:t>recall en la corrida de referencia (v1)</a:t>
             </a:r>
             <a:endParaRPr lang="en-US" sz="1250" dirty="0"/>
           </a:p>
@@ -11624,6 +11680,10 @@
             <a:prstDash val="solid"/>
           </a:ln>
         </p:spPr>
+        <p:txBody>
+          <a:bodyPr/>
+          <a:p/>
+        </p:txBody>
       </p:sp>
       <p:sp>
         <p:nvSpPr>
@@ -11889,7 +11949,7 @@
                   <a:schemeClr val="tx2"/>
                 </a:solidFill>
               </a:rPr>
-              <a:t>recall@10 de vecinos con Jaccard ≥ 0,5</a:t>
+              <a:t>recall@10 con Jaccard ≥ 0,5; global 2,9 %</a:t>
             </a:r>
             <a:endParaRPr lang="en-US" sz="1250" dirty="0"/>
           </a:p>

</xml_diff>

<commit_message>
docs: apunta las laminas y los scripts al repositorio de la organizacion
</commit_message>
<xml_diff>
--- a/report/Presentacion_Final.pptx
+++ b/report/Presentacion_Final.pptx
@@ -7187,6 +7187,10 @@
             <a:prstDash val="solid"/>
           </a:ln>
         </p:spPr>
+        <p:txBody>
+          <a:bodyPr/>
+          <a:p/>
+        </p:txBody>
       </p:sp>
       <p:sp>
         <p:nvSpPr>
@@ -7325,6 +7329,10 @@
             <a:prstDash val="solid"/>
           </a:ln>
         </p:spPr>
+        <p:txBody>
+          <a:bodyPr/>
+          <a:p/>
+        </p:txBody>
       </p:sp>
       <p:sp>
         <p:nvSpPr>
@@ -7463,6 +7471,10 @@
             <a:prstDash val="solid"/>
           </a:ln>
         </p:spPr>
+        <p:txBody>
+          <a:bodyPr/>
+          <a:p/>
+        </p:txBody>
       </p:sp>
       <p:sp>
         <p:nvSpPr>
@@ -7601,6 +7613,10 @@
             <a:prstDash val="solid"/>
           </a:ln>
         </p:spPr>
+        <p:txBody>
+          <a:bodyPr/>
+          <a:p/>
+        </p:txBody>
       </p:sp>
       <p:sp>
         <p:nvSpPr>
@@ -7743,7 +7759,7 @@
                   <a:schemeClr val="accent6"/>
                 </a:solidFill>
               </a:rPr>
-              <a:t>github.com/dantebarreto-gif/Proyecto-Final-E-AD</a:t>
+              <a:t>github.com/UTEC-AII/Proyecto-Final-E-AD</a:t>
             </a:r>
             <a:endParaRPr lang="en-US" sz="1200" dirty="0"/>
           </a:p>
@@ -7918,6 +7934,10 @@
             <a:prstDash val="solid"/>
           </a:ln>
         </p:spPr>
+        <p:txBody>
+          <a:bodyPr/>
+          <a:p/>
+        </p:txBody>
       </p:sp>
       <p:pic>
         <p:nvPicPr>
@@ -8044,6 +8064,10 @@
             <a:prstDash val="solid"/>
           </a:ln>
         </p:spPr>
+        <p:txBody>
+          <a:bodyPr/>
+          <a:p/>
+        </p:txBody>
       </p:sp>
       <p:pic>
         <p:nvPicPr>
@@ -8170,6 +8194,10 @@
             <a:prstDash val="solid"/>
           </a:ln>
         </p:spPr>
+        <p:txBody>
+          <a:bodyPr/>
+          <a:p/>
+        </p:txBody>
       </p:sp>
       <p:pic>
         <p:nvPicPr>
@@ -8296,6 +8324,10 @@
             <a:prstDash val="solid"/>
           </a:ln>
         </p:spPr>
+        <p:txBody>
+          <a:bodyPr/>
+          <a:p/>
+        </p:txBody>
       </p:sp>
       <p:pic>
         <p:nvPicPr>
@@ -9769,6 +9801,10 @@
             <a:prstDash val="solid"/>
           </a:ln>
         </p:spPr>
+        <p:txBody>
+          <a:bodyPr/>
+          <a:p/>
+        </p:txBody>
       </p:sp>
       <p:sp>
         <p:nvSpPr>
@@ -9796,6 +9832,10 @@
             <a:prstDash val="solid"/>
           </a:ln>
         </p:spPr>
+        <p:txBody>
+          <a:bodyPr/>
+          <a:p/>
+        </p:txBody>
       </p:sp>
       <p:sp>
         <p:nvSpPr>
@@ -10157,6 +10197,10 @@
             <a:prstDash val="solid"/>
           </a:ln>
         </p:spPr>
+        <p:txBody>
+          <a:bodyPr/>
+          <a:p/>
+        </p:txBody>
       </p:sp>
       <p:sp>
         <p:nvSpPr>
@@ -10184,6 +10228,10 @@
             <a:prstDash val="solid"/>
           </a:ln>
         </p:spPr>
+        <p:txBody>
+          <a:bodyPr/>
+          <a:p/>
+        </p:txBody>
       </p:sp>
       <p:sp>
         <p:nvSpPr>
@@ -10437,6 +10485,10 @@
             <a:prstDash val="solid"/>
           </a:ln>
         </p:spPr>
+        <p:txBody>
+          <a:bodyPr/>
+          <a:p/>
+        </p:txBody>
       </p:sp>
       <p:sp>
         <p:nvSpPr>
@@ -10464,6 +10516,10 @@
             <a:prstDash val="solid"/>
           </a:ln>
         </p:spPr>
+        <p:txBody>
+          <a:bodyPr/>
+          <a:p/>
+        </p:txBody>
       </p:sp>
       <p:sp>
         <p:nvSpPr>
@@ -10717,6 +10773,10 @@
             <a:prstDash val="solid"/>
           </a:ln>
         </p:spPr>
+        <p:txBody>
+          <a:bodyPr/>
+          <a:p/>
+        </p:txBody>
       </p:sp>
       <p:sp>
         <p:nvSpPr>
@@ -10744,6 +10804,10 @@
             <a:prstDash val="solid"/>
           </a:ln>
         </p:spPr>
+        <p:txBody>
+          <a:bodyPr/>
+          <a:p/>
+        </p:txBody>
       </p:sp>
       <p:sp>
         <p:nvSpPr>
@@ -12255,6 +12319,10 @@
             <a:prstDash val="solid"/>
           </a:ln>
         </p:spPr>
+        <p:txBody>
+          <a:bodyPr/>
+          <a:p/>
+        </p:txBody>
       </p:sp>
       <p:sp>
         <p:nvSpPr>

</xml_diff>

<commit_message>
docs(resultados): corrida definitiva de 10M con el codigo final
- Nuevas cifras: 308,8 s (33,107 eventos/s), 66,628 bloqueados con 95,4 % de
  precision y 88,1 % de exhaustividad, 179,043 ordenes indexadas.
- Informe, README, laminas y results/demo actualizados; se elimina la nota de
  corrida de referencia.
</commit_message>
<xml_diff>
--- a/report/Presentacion_Final.pptx
+++ b/report/Presentacion_Final.pptx
@@ -6770,7 +6770,7 @@
                   <a:schemeClr val="tx1"/>
                 </a:solidFill>
               </a:rPr>
-              <a:t>La corrida completa: 10.2M eventos reales en 21 minutos</a:t>
+              <a:t>La corrida completa: 10.2M eventos reales en 5 minutos</a:t>
             </a:r>
             <a:endParaRPr lang="en-US" sz="2800" dirty="0"/>
           </a:p>
@@ -6825,7 +6825,7 @@
                 <a:ea typeface="Cambria" pitchFamily="34" charset="-122"/>
                 <a:cs typeface="Cambria" pitchFamily="34" charset="-120"/>
               </a:rPr>
-              <a:t>8,204 ev/s</a:t>
+              <a:t>33,107 ev/s</a:t>
             </a:r>
             <a:endParaRPr lang="en-US" sz="3600" dirty="0"/>
           </a:p>
@@ -6900,7 +6900,7 @@
                 <a:ea typeface="Cambria" pitchFamily="34" charset="-122"/>
                 <a:cs typeface="Cambria" pitchFamily="34" charset="-120"/>
               </a:rPr>
-              <a:t>178,145</a:t>
+              <a:t>179,043</a:t>
             </a:r>
             <a:endParaRPr lang="en-US" sz="3600" dirty="0"/>
           </a:p>
@@ -6975,7 +6975,7 @@
                 <a:ea typeface="Cambria" pitchFamily="34" charset="-122"/>
                 <a:cs typeface="Cambria" pitchFamily="34" charset="-120"/>
               </a:rPr>
-              <a:t>70,682</a:t>
+              <a:t>66,628</a:t>
             </a:r>
             <a:endParaRPr lang="en-US" sz="3600" dirty="0"/>
           </a:p>
@@ -7011,7 +7011,7 @@
                   <a:schemeClr val="tx2"/>
                 </a:solidFill>
               </a:rPr>
-              <a:t>bloqueados en la corrida de referencia (v1)</a:t>
+              <a:t>eventos bloqueados antes de llegar a S4</a:t>
             </a:r>
             <a:endParaRPr lang="en-US" sz="1250" dirty="0"/>
           </a:p>
@@ -11327,7 +11327,7 @@
                 <a:ea typeface="Cambria" pitchFamily="34" charset="-122"/>
                 <a:cs typeface="Cambria" pitchFamily="34" charset="-120"/>
               </a:rPr>
-              <a:t>92.9 %</a:t>
+              <a:t>95.4 %</a:t>
             </a:r>
             <a:endParaRPr lang="en-US" sz="3600" dirty="0"/>
           </a:p>
@@ -11363,7 +11363,7 @@
                   <a:schemeClr val="tx2"/>
                 </a:solidFill>
               </a:rPr>
-              <a:t>precisión en la corrida de referencia (v1)</a:t>
+              <a:t>precisión sobre los 10M eventos</a:t>
             </a:r>
             <a:endParaRPr lang="en-US" sz="1250" dirty="0"/>
           </a:p>
@@ -11402,7 +11402,7 @@
                 <a:ea typeface="Cambria" pitchFamily="34" charset="-122"/>
                 <a:cs typeface="Cambria" pitchFamily="34" charset="-120"/>
               </a:rPr>
-              <a:t>91.1 %</a:t>
+              <a:t>88.1 %</a:t>
             </a:r>
             <a:endParaRPr lang="en-US" sz="3600" dirty="0"/>
           </a:p>
@@ -11438,7 +11438,7 @@
                   <a:schemeClr val="tx2"/>
                 </a:solidFill>
               </a:rPr>
-              <a:t>recall en la corrida de referencia (v1)</a:t>
+              <a:t>recall sobre los 10M eventos</a:t>
             </a:r>
             <a:endParaRPr lang="en-US" sz="1250" dirty="0"/>
           </a:p>

</xml_diff>

<commit_message>
docs: alinea informe, diapositivas y README con el S1 final
- Informe: tabla de estructuras, seccion 4.2, correcciones y validacion de S1
- Diapositivas regeneradas desde results/: cifras de la corrida final en S8,
  la demo y la corrida de 10M; Bloom con p = 0,1 % y k = 10; notas con la
  precision y el recall vigentes; se elimina la diapositiva vacia
- README, CONTRIBUTING y plantilla de PR: S1 y 20 pruebas
</commit_message>
<xml_diff>
--- a/report/Presentacion_Final.pptx
+++ b/report/Presentacion_Final.pptx
@@ -18,7 +18,6 @@
     <p:sldId id="266" r:id="rId12"/>
     <p:sldId id="267" r:id="rId13"/>
     <p:sldId id="268" r:id="rId14"/>
-    <p:sldId id="269" r:id="rId20"/>
   </p:sldIdLst>
   <p:notesMasterIdLst>
     <p:notesMasterId r:id="rId15"/>
@@ -120,19 +119,19 @@
   <p:extLst>
     <p:ext uri="{521415D9-36F7-43E2-AB2F-B90AF26B5E84}">
       <p14:sectionLst xmlns:p14="http://schemas.microsoft.com/office/powerpoint/2010/main">
-        <p14:section name="Introducción" id="{8738394a-c9b4-9152-35aa-ad3c0eed0920}">
+        <p14:section name="Introducción" id="{85536a1b-e57b-f989-e472-a483dfe15fdc}">
           <p14:sldIdLst>
             <p14:sldId id="256"/>
             <p14:sldId id="257"/>
             <p14:sldId id="258"/>
           </p14:sldIdLst>
         </p14:section>
-        <p14:section name="Arquitectura" id="{02fa399c-3c18-9474-5772-aea7826d4cba}">
+        <p14:section name="Arquitectura" id="{67496255-967e-aa77-6895-a6d180ba565a}">
           <p14:sldIdLst>
             <p14:sldId id="259"/>
           </p14:sldIdLst>
         </p14:section>
-        <p14:section name="Etapas" id="{5f0f3740-f894-d0e8-7462-ec4ccc5e64b8}">
+        <p14:section name="Etapas" id="{25116843-a27f-88f8-8c56-a3dd8ea6d007}">
           <p14:sldIdLst>
             <p14:sldId id="260"/>
             <p14:sldId id="261"/>
@@ -141,14 +140,14 @@
             <p14:sldId id="264"/>
           </p14:sldIdLst>
         </p14:section>
-        <p14:section name="Resultados" id="{dbdc4c92-881c-f91b-7818-1024676bcbc5}">
+        <p14:section name="Resultados" id="{8580baf1-4815-18f8-8bd0-badf156d39b2}">
           <p14:sldIdLst>
             <p14:sldId id="265"/>
             <p14:sldId id="266"/>
             <p14:sldId id="267"/>
           </p14:sldIdLst>
         </p14:section>
-        <p14:section name="Cierre" id="{7c7e9005-ebf3-9fbc-7b3f-1cacafafcc0e}">
+        <p14:section name="Cierre" id="{aadc9026-e73c-d60d-7527-72a0b5ab80ff}">
           <p14:sldIdLst>
             <p14:sldId id="268"/>
           </p14:sldIdLst>
@@ -1105,7 +1104,7 @@
                 <c:formatCode>General</c:formatCode>
                 <c:ptCount val="2"/>
                 <c:pt idx="0">
-                  <c:v>0.626</c:v>
+                  <c:v>0.621</c:v>
                 </c:pt>
                 <c:pt idx="1">
                   <c:v>0.781</c:v>
@@ -1182,7 +1181,7 @@
                 <c:formatCode>General</c:formatCode>
                 <c:ptCount val="2"/>
                 <c:pt idx="0">
-                  <c:v>0.394</c:v>
+                  <c:v>0.383</c:v>
                 </c:pt>
                 <c:pt idx="1">
                   <c:v>0.75</c:v>
@@ -1457,10 +1456,10 @@
                     <c:v>S8 grafo</c:v>
                   </c:pt>
                   <c:pt idx="3">
-                    <c:v>S8 refresco PageRank+Louvain</c:v>
+                    <c:v>S5 refresco KD-Tree</c:v>
                   </c:pt>
                   <c:pt idx="4">
-                    <c:v>S5 refresco KD-Tree</c:v>
+                    <c:v>S8 refresco PageRank+Louvain</c:v>
                   </c:pt>
                   <c:pt idx="5">
                     <c:v>S4 B+Tree</c:v>
@@ -1478,10 +1477,10 @@
                     <c:v>S6 filtrado</c:v>
                   </c:pt>
                   <c:pt idx="10">
-                    <c:v>S1 preprocesamiento</c:v>
+                    <c:v>S2 prioridad</c:v>
                   </c:pt>
                   <c:pt idx="11">
-                    <c:v>S2 prioridad</c:v>
+                    <c:v>S1 preprocesamiento</c:v>
                   </c:pt>
                   <c:pt idx="12">
                     <c:v>S0 ingesta</c:v>
@@ -1500,46 +1499,46 @@
                 <c:formatCode>General</c:formatCode>
                 <c:ptCount val="14"/>
                 <c:pt idx="0">
-                  <c:v>0.2</c:v>
+                  <c:v>0</c:v>
                 </c:pt>
                 <c:pt idx="1">
+                  <c:v>0.1</c:v>
+                </c:pt>
+                <c:pt idx="2">
                   <c:v>0.4</c:v>
                 </c:pt>
-                <c:pt idx="2">
-                  <c:v>1.5</c:v>
-                </c:pt>
                 <c:pt idx="3">
-                  <c:v>2.2</c:v>
+                  <c:v>0.6</c:v>
                 </c:pt>
                 <c:pt idx="4">
-                  <c:v>2.6</c:v>
+                  <c:v>0.7</c:v>
                 </c:pt>
                 <c:pt idx="5">
-                  <c:v>3.8</c:v>
+                  <c:v>0.8</c:v>
                 </c:pt>
                 <c:pt idx="6">
-                  <c:v>6.7</c:v>
+                  <c:v>1.8</c:v>
                 </c:pt>
                 <c:pt idx="7">
-                  <c:v>38</c:v>
+                  <c:v>11</c:v>
                 </c:pt>
                 <c:pt idx="8">
-                  <c:v>45.9</c:v>
+                  <c:v>13.7</c:v>
                 </c:pt>
                 <c:pt idx="9">
-                  <c:v>50.3</c:v>
+                  <c:v>18.7</c:v>
                 </c:pt>
                 <c:pt idx="10">
-                  <c:v>69.5</c:v>
+                  <c:v>20.1</c:v>
                 </c:pt>
                 <c:pt idx="11">
-                  <c:v>78.6</c:v>
+                  <c:v>29.5</c:v>
                 </c:pt>
                 <c:pt idx="12">
-                  <c:v>258.5</c:v>
+                  <c:v>58.2</c:v>
                 </c:pt>
                 <c:pt idx="13">
-                  <c:v>680.1</c:v>
+                  <c:v>151</c:v>
                 </c:pt>
               </c:numCache>
             </c:numRef>
@@ -2261,7 +2260,7 @@
           <a:p>
             <a:r>
               <a:rPr lang="en-US" dirty="0"/>
-              <a:t>Presenta: Sebastian. Demo en vivo de 3 a 4 minutos: python scripts/run_pipeline.py --data data/synthetic_200000 y luego el panel con streamlit run src/eda/service/dashboard.py. A la izquierda está la traza literal de una compra de la corrida de 10M: entra a la cola, pasa la limpieza, sale tercera del heap, se resuelve en la tabla hash, pasa el filtro, se indexa en el B+Tree y termina en recomendaciones que combinan grafo, IVF y KD-Tree.</a:t>
+              <a:t>Presenta: Sebastian. Demo en vivo de 3 a 4 minutos: python scripts/run_pipeline.py --data data/synthetic_200000 y luego el panel con streamlit run src/eda/service/dashboard.py. A la izquierda está la traza literal de una compra de la corrida de 10M: entra a la cola, pasa la limpieza, el heap la deja detrás de las compras express, premium y estándar del lote, se resuelve en la tabla hash, pasa el filtro, se indexa en el B+Tree y termina en recomendaciones que combinan grafo, IVF y KD-Tree.</a:t>
             </a:r>
             <a:endParaRPr lang="en-US" dirty="0"/>
           </a:p>
@@ -2789,7 +2788,7 @@
           <a:p>
             <a:r>
               <a:rPr lang="en-US" dirty="0"/>
-              <a:t>Presenta: Sebastian. S0 es una cola enlazada con capacidad, que da backpressure. S1 elimina duplicados buscando cada id en una ventana ordenada con búsqueda binaria, sin guardar todos los ids. S2 es un heap: las compras express salen primero. Las pendientes medidas están cerca de lo esperado.</a:t>
+              <a:t>Presenta: Sebastian. S0 es una cola enlazada con capacidad, que da backpressure. S1 ordena el lote con merge sort, elimina los repetidos adyacentes y busca cada id con búsqueda binaria en las corridas ordenadas de los últimos 500 mil ids; cuando la ventana se llena descarta la corrida más antigua entera, así que nunca mezcla la ventana completa. S2 es un heap: las compras express salen primero. Las pendientes medidas están cerca de lo esperado.</a:t>
             </a:r>
             <a:endParaRPr lang="en-US" dirty="0"/>
           </a:p>
@@ -2965,7 +2964,7 @@
           <a:p>
             <a:r>
               <a:rPr lang="en-US" dirty="0"/>
-              <a:t>Presenta: Clinton. El Bloom guarda la lista negra en pocos kilobytes y no tiene falsos negativos. Como un falso positivo bloquearía una compra legítima, cada positivo se verifica contra el conjunto exacto. El Count-Min cuenta intentos por tarjeta en una ventana deslizante de 10 minutos; nunca subestima, así que no oculta una ráfaga. El recall es 91 % porque los primeros intentos de cada ráfaga pasan antes de llegar al umbral. La precisión es 93 % porque en los datos reales hay unas 300 cuentas con hasta 110 carritos o compras en 10 minutos: parecen bots o revendedores, y en producción irían a revisión manual. Con datos sintéticos la precisión fue 99,998 %.</a:t>
+              <a:t>Presenta: Clinton. El Bloom guarda la lista negra en pocos kilobytes y no tiene falsos negativos. Como un falso positivo bloquearía una compra legítima, cada positivo se verifica contra el conjunto exacto. El Count-Min cuenta intentos por tarjeta en una ventana deslizante de 10 minutos; nunca subestima, así que no oculta una ráfaga. El recall es 88.1 % porque los primeros intentos de cada ráfaga pasan antes de llegar al umbral. La precisión es 95.4 % porque en los datos reales hay unas 300 cuentas con hasta 110 carritos o compras en 10 minutos: parecen bots o revendedores, y en producción irían a revisión manual. Con datos sintéticos la precisión fue 99,998 %.</a:t>
             </a:r>
             <a:endParaRPr lang="en-US" dirty="0"/>
           </a:p>
@@ -4117,7 +4116,7 @@
         <p:spPr>
           <a:xfrm>
             <a:off x="548640" y="1325880"/>
-            <a:ext cx="6949440" cy="4168961"/>
+            <a:ext cx="6949440" cy="4117543"/>
           </a:xfrm>
           <a:prstGeom prst="rect">
             <a:avLst/>
@@ -6414,7 +6413,7 @@
                   <a:schemeClr val="tx1"/>
                 </a:solidFill>
               </a:rPr>
-              <a:t>Demo: el recorrido de una compra express por las etapas</a:t>
+              <a:t>Demo: el recorrido de una compra por las diez etapas</a:t>
             </a:r>
             <a:endParaRPr lang="en-US" sz="2800" dirty="0"/>
           </a:p>
@@ -6458,7 +6457,7 @@
                 <a:ea typeface="Courier New" pitchFamily="34" charset="-122"/>
                 <a:cs typeface="Courier New" pitchFamily="34" charset="-120"/>
               </a:rPr>
-              <a:t>Event(id=6966919, purchase, product=1004856, user=528344847, price=131.76)</a:t>
+              <a:t>Event(id=6967856, purchase, product=1004856, user=528344847, price=131.76)</a:t>
             </a:r>
             <a:endParaRPr lang="en-US" sz="1100" dirty="0"/>
           </a:p>
@@ -6478,7 +6477,7 @@
                 <a:ea typeface="Courier New" pitchFamily="34" charset="-122"/>
                 <a:cs typeface="Courier New" pitchFamily="34" charset="-120"/>
               </a:rPr>
-              <a:t>[S0] encolado (cola=1413)</a:t>
+              <a:t>[S0] encolado (cola=2366)</a:t>
             </a:r>
             <a:endParaRPr lang="en-US" sz="1100" dirty="0"/>
           </a:p>
@@ -6518,7 +6517,7 @@
                 <a:ea typeface="Courier New" pitchFamily="34" charset="-122"/>
                 <a:cs typeface="Courier New" pitchFamily="34" charset="-120"/>
               </a:rPr>
-              <a:t>[S2] prioridad 3 (compra programada), posición 133 de 4929 en el lote</a:t>
+              <a:t>[S2] prioridad 3 (compra programada), posición 89 de 4929 en el lote</a:t>
             </a:r>
             <a:endParaRPr lang="en-US" sz="1100" dirty="0"/>
           </a:p>
@@ -6538,7 +6537,7 @@
                 <a:ea typeface="Courier New" pitchFamily="34" charset="-122"/>
                 <a:cs typeface="Courier New" pitchFamily="34" charset="-120"/>
               </a:rPr>
-              <a:t>[S3] producto #861 y usuario #746718 resueltos en la tabla hash</a:t>
+              <a:t>[S3] producto #861 y usuario #746725 resueltos en la tabla hash</a:t>
             </a:r>
             <a:endParaRPr lang="en-US" sz="1100" dirty="0"/>
           </a:p>
@@ -6618,7 +6617,7 @@
                 <a:ea typeface="Courier New" pitchFamily="34" charset="-122"/>
                 <a:cs typeface="Courier New" pitchFamily="34" charset="-120"/>
               </a:rPr>
-              <a:t>[S7] relacionados LSH: []; vecinos IVF: [87190, 87862, 40728]</a:t>
+              <a:t>[S7] relacionados LSH: []; vecinos IVF: [87862, 87190, 40728]</a:t>
             </a:r>
             <a:endParaRPr lang="en-US" sz="1100" dirty="0"/>
           </a:p>
@@ -7011,7 +7010,7 @@
                   <a:schemeClr val="tx2"/>
                 </a:solidFill>
               </a:rPr>
-              <a:t>eventos bloqueados antes de llegar a S4</a:t>
+              <a:t>eventos de fraude bloqueados antes de llegar a S4</a:t>
             </a:r>
             <a:endParaRPr lang="en-US" sz="1250" dirty="0"/>
           </a:p>
@@ -7187,10 +7186,6 @@
             <a:prstDash val="solid"/>
           </a:ln>
         </p:spPr>
-        <p:txBody>
-          <a:bodyPr/>
-          <a:p/>
-        </p:txBody>
       </p:sp>
       <p:sp>
         <p:nvSpPr>
@@ -7329,10 +7324,6 @@
             <a:prstDash val="solid"/>
           </a:ln>
         </p:spPr>
-        <p:txBody>
-          <a:bodyPr/>
-          <a:p/>
-        </p:txBody>
       </p:sp>
       <p:sp>
         <p:nvSpPr>
@@ -7471,10 +7462,6 @@
             <a:prstDash val="solid"/>
           </a:ln>
         </p:spPr>
-        <p:txBody>
-          <a:bodyPr/>
-          <a:p/>
-        </p:txBody>
       </p:sp>
       <p:sp>
         <p:nvSpPr>
@@ -7613,10 +7600,6 @@
             <a:prstDash val="solid"/>
           </a:ln>
         </p:spPr>
-        <p:txBody>
-          <a:bodyPr/>
-          <a:p/>
-        </p:txBody>
       </p:sp>
       <p:sp>
         <p:nvSpPr>
@@ -7808,41 +7791,6 @@
             </a:fld>
             <a:endParaRPr lang="en-US"/>
           </a:p>
-        </p:txBody>
-      </p:sp>
-    </p:spTree>
-  </p:cSld>
-  <p:clrMapOvr>
-    <a:masterClrMapping/>
-  </p:clrMapOvr>
-</p:sld>
-</file>
-
-<file path=ppt/slides/slide14.xml><?xml version="1.0" encoding="utf-8"?>
-<p:sld xmlns:a="http://schemas.openxmlformats.org/drawingml/2006/main" xmlns:p="http://schemas.openxmlformats.org/presentationml/2006/main" xmlns:r="http://schemas.openxmlformats.org/officeDocument/2006/relationships">
-  <p:cSld>
-    <p:spTree>
-      <p:nvGrpSpPr>
-        <p:cNvPr id="1" name=""/>
-        <p:cNvGrpSpPr/>
-        <p:nvPr/>
-      </p:nvGrpSpPr>
-      <p:grpSpPr/>
-      <p:sp>
-        <p:nvSpPr>
-          <p:cNvPr id="2" name="Title 1"/>
-          <p:cNvSpPr>
-            <a:spLocks noGrp="1"/>
-          </p:cNvSpPr>
-          <p:nvPr>
-            <p:ph type="title" idx="100"/>
-          </p:nvPr>
-        </p:nvSpPr>
-        <p:spPr/>
-        <p:txBody>
-          <a:bodyPr/>
-          <a:lstStyle/>
-          <a:p/>
         </p:txBody>
       </p:sp>
     </p:spTree>
@@ -7934,10 +7882,6 @@
             <a:prstDash val="solid"/>
           </a:ln>
         </p:spPr>
-        <p:txBody>
-          <a:bodyPr/>
-          <a:p/>
-        </p:txBody>
       </p:sp>
       <p:pic>
         <p:nvPicPr>
@@ -8064,10 +8008,6 @@
             <a:prstDash val="solid"/>
           </a:ln>
         </p:spPr>
-        <p:txBody>
-          <a:bodyPr/>
-          <a:p/>
-        </p:txBody>
       </p:sp>
       <p:pic>
         <p:nvPicPr>
@@ -8194,10 +8134,6 @@
             <a:prstDash val="solid"/>
           </a:ln>
         </p:spPr>
-        <p:txBody>
-          <a:bodyPr/>
-          <a:p/>
-        </p:txBody>
       </p:sp>
       <p:pic>
         <p:nvPicPr>
@@ -8324,10 +8260,6 @@
             <a:prstDash val="solid"/>
           </a:ln>
         </p:spPr>
-        <p:txBody>
-          <a:bodyPr/>
-          <a:p/>
-        </p:txBody>
       </p:sp>
       <p:pic>
         <p:nvPicPr>
@@ -9225,10 +9157,6 @@
             <a:prstDash val="solid"/>
           </a:ln>
         </p:spPr>
-        <p:txBody>
-          <a:bodyPr/>
-          <a:p/>
-        </p:txBody>
       </p:sp>
       <p:sp>
         <p:nvSpPr>
@@ -9256,10 +9184,6 @@
             <a:prstDash val="solid"/>
           </a:ln>
         </p:spPr>
-        <p:txBody>
-          <a:bodyPr/>
-          <a:p/>
-        </p:txBody>
       </p:sp>
       <p:sp>
         <p:nvSpPr>
@@ -9513,10 +9437,6 @@
             <a:prstDash val="solid"/>
           </a:ln>
         </p:spPr>
-        <p:txBody>
-          <a:bodyPr/>
-          <a:p/>
-        </p:txBody>
       </p:sp>
       <p:sp>
         <p:nvSpPr>
@@ -9544,10 +9464,6 @@
             <a:prstDash val="solid"/>
           </a:ln>
         </p:spPr>
-        <p:txBody>
-          <a:bodyPr/>
-          <a:p/>
-        </p:txBody>
       </p:sp>
       <p:sp>
         <p:nvSpPr>
@@ -9676,7 +9592,7 @@
                   <a:schemeClr val="tx2"/>
                 </a:solidFill>
               </a:rPr>
-              <a:t>Deduplica contra una ventana de 500 mil ids con conjunto hash</a:t>
+              <a:t>Busca cada id con búsqueda binaria en las corridas ordenadas de los últimos 500K</a:t>
             </a:r>
             <a:endParaRPr lang="en-US" sz="1500" dirty="0"/>
           </a:p>
@@ -9694,7 +9610,7 @@
                   <a:schemeClr val="tx2"/>
                 </a:solidFill>
               </a:rPr>
-              <a:t>O(1) por evento; memoria acotada a la ventana</a:t>
+              <a:t>O(b log b) por corrida solapada; expira la corrida más antigua</a:t>
             </a:r>
             <a:endParaRPr lang="en-US" sz="1500" dirty="0"/>
           </a:p>
@@ -9801,10 +9717,6 @@
             <a:prstDash val="solid"/>
           </a:ln>
         </p:spPr>
-        <p:txBody>
-          <a:bodyPr/>
-          <a:p/>
-        </p:txBody>
       </p:sp>
       <p:sp>
         <p:nvSpPr>
@@ -9832,10 +9744,6 @@
             <a:prstDash val="solid"/>
           </a:ln>
         </p:spPr>
-        <p:txBody>
-          <a:bodyPr/>
-          <a:p/>
-        </p:txBody>
       </p:sp>
       <p:sp>
         <p:nvSpPr>
@@ -10197,10 +10105,6 @@
             <a:prstDash val="solid"/>
           </a:ln>
         </p:spPr>
-        <p:txBody>
-          <a:bodyPr/>
-          <a:p/>
-        </p:txBody>
       </p:sp>
       <p:sp>
         <p:nvSpPr>
@@ -10228,10 +10132,6 @@
             <a:prstDash val="solid"/>
           </a:ln>
         </p:spPr>
-        <p:txBody>
-          <a:bodyPr/>
-          <a:p/>
-        </p:txBody>
       </p:sp>
       <p:sp>
         <p:nvSpPr>
@@ -10378,7 +10278,7 @@
                   <a:schemeClr val="tx2"/>
                 </a:solidFill>
               </a:rPr>
-              <a:t>Matriz usuario × producto: 5,808,668 celdas</a:t>
+              <a:t>Matriz usuario × producto: 5,808,669 celdas</a:t>
             </a:r>
             <a:endParaRPr lang="en-US" sz="1500" dirty="0"/>
           </a:p>
@@ -10485,10 +10385,6 @@
             <a:prstDash val="solid"/>
           </a:ln>
         </p:spPr>
-        <p:txBody>
-          <a:bodyPr/>
-          <a:p/>
-        </p:txBody>
       </p:sp>
       <p:sp>
         <p:nvSpPr>
@@ -10516,10 +10412,6 @@
             <a:prstDash val="solid"/>
           </a:ln>
         </p:spPr>
-        <p:txBody>
-          <a:bodyPr/>
-          <a:p/>
-        </p:txBody>
       </p:sp>
       <p:sp>
         <p:nvSpPr>
@@ -10773,10 +10665,6 @@
             <a:prstDash val="solid"/>
           </a:ln>
         </p:spPr>
-        <p:txBody>
-          <a:bodyPr/>
-          <a:p/>
-        </p:txBody>
       </p:sp>
       <p:sp>
         <p:nvSpPr>
@@ -10804,10 +10692,6 @@
             <a:prstDash val="solid"/>
           </a:ln>
         </p:spPr>
-        <p:txBody>
-          <a:bodyPr/>
-          <a:p/>
-        </p:txBody>
       </p:sp>
       <p:sp>
         <p:nvSpPr>
@@ -11169,10 +11053,6 @@
             <a:prstDash val="solid"/>
           </a:ln>
         </p:spPr>
-        <p:txBody>
-          <a:bodyPr/>
-          <a:p/>
-        </p:txBody>
       </p:sp>
       <p:sp>
         <p:nvSpPr>
@@ -11257,7 +11137,7 @@
                   <a:schemeClr val="tx2"/>
                 </a:solidFill>
               </a:rPr>
-              <a:t>lista negra de tarjetas y dispositivos, p = 1 %, k = 7. Todo positivo se verifica contra el conjunto exacto antes de bloquear.</a:t>
+              <a:t>lista negra de tarjetas y dispositivos, p = 0,1 %, k = 10. Todo positivo se verifica contra el conjunto exacto antes de bloquear.</a:t>
             </a:r>
             <a:endParaRPr lang="en-US" sz="1500" dirty="0"/>
           </a:p>
@@ -11744,10 +11624,6 @@
             <a:prstDash val="solid"/>
           </a:ln>
         </p:spPr>
-        <p:txBody>
-          <a:bodyPr/>
-          <a:p/>
-        </p:txBody>
       </p:sp>
       <p:sp>
         <p:nvSpPr>
@@ -12319,10 +12195,6 @@
             <a:prstDash val="solid"/>
           </a:ln>
         </p:spPr>
-        <p:txBody>
-          <a:bodyPr/>
-          <a:p/>
-        </p:txBody>
       </p:sp>
       <p:sp>
         <p:nvSpPr>
@@ -12477,7 +12349,7 @@
                 <a:ea typeface="Cambria" pitchFamily="34" charset="-122"/>
                 <a:cs typeface="Cambria" pitchFamily="34" charset="-120"/>
               </a:rPr>
-              <a:t>6,901</a:t>
+              <a:t>6,921</a:t>
             </a:r>
             <a:endParaRPr lang="en-US" sz="3600" dirty="0"/>
           </a:p>
@@ -12513,7 +12385,7 @@
                   <a:schemeClr val="tx2"/>
                 </a:solidFill>
               </a:rPr>
-              <a:t>productos y 14,035 aristas en la corrida de 10M</a:t>
+              <a:t>productos y 14,176 aristas en la corrida de 10M</a:t>
             </a:r>
             <a:endParaRPr lang="en-US" sz="1250" dirty="0"/>
           </a:p>
@@ -12552,7 +12424,7 @@
                 <a:ea typeface="Cambria" pitchFamily="34" charset="-122"/>
                 <a:cs typeface="Cambria" pitchFamily="34" charset="-120"/>
               </a:rPr>
-              <a:t>0.13 s</a:t>
+              <a:t>0.03 s</a:t>
             </a:r>
             <a:endParaRPr lang="en-US" sz="3600" dirty="0"/>
           </a:p>

</xml_diff>

<commit_message>
docs(laminas): corrige el comando de la demo y la configuracion del Bloom
- Lamina 13: el comando lleva --refresh 50000, sin el cual no aparecen S5 ni S7.
- Lamina 8: la cifra de 12 MB frente a 268 MB es del banco de pruebas con
  p = 1 %, no del Bloom del pipeline (p = 0,1 %).
</commit_message>
<xml_diff>
--- a/report/Presentacion_Final.pptx
+++ b/report/Presentacion_Final.pptx
@@ -8040,7 +8040,7 @@
                 <a:ea typeface="Courier New" pitchFamily="34" charset="-122"/>
                 <a:cs typeface="Courier New" pitchFamily="34" charset="-120"/>
               </a:rPr>
-              <a:t>python scripts/run_pipeline.py --data data/rees46_200000</a:t>
+              <a:t>python scripts/run_pipeline.py --data data/rees46_200000 --refresh 50000</a:t>
             </a:r>
             <a:endParaRPr lang="en-US" sz="1100" dirty="0"/>
           </a:p>
@@ -16938,7 +16938,7 @@
                   <a:schemeClr val="accent5"/>
                 </a:solidFill>
               </a:rPr>
-              <a:t>Con 10M claves: 12 MB frente a 268 MB (22 veces menos). FP medido 1,01 % con p = 1 %.</a:t>
+              <a:t>En el banco de pruebas, con p = 1 % y 10M claves: 12 MB frente a 268 MB, y FP medido de 1,01 %.</a:t>
             </a:r>
             <a:endParaRPr lang="en-US" sz="1200" dirty="0"/>
           </a:p>

</xml_diff>